<commit_message>
Use sourced statistics in AI Trend comparison box
Co-Authored-By: Claude Opus 5.5 <noreply@anthropic.com>
Claude-Session: https://claude.ai/code/session_014TbtPTXZRwab3hp8YY9eJi
</commit_message>
<xml_diff>
--- a/02_AI_Trend.pptx
+++ b/02_AI_Trend.pptx
@@ -5016,7 +5016,7 @@
           <a:p>
             <a:pPr algn="ctr"/>
             <a:r>
-              <a:rPr sz="1300" b="1" i="0" u="none">
+              <a:rPr sz="1200" b="1" i="0" u="none">
                 <a:solidFill>
                   <a:srgbClr val="FFFFFF"/>
                 </a:solidFill>
@@ -5024,7 +5024,7 @@
                 <a:ea typeface="맑은 고딕"/>
                 <a:cs typeface="맑은 고딕"/>
               </a:rPr>
-              <a:t>과제 검증 기간</a:t>
+              <a:t>개발 과제 완료 시간 ①</a:t>
             </a:r>
           </a:p>
         </p:txBody>
@@ -5037,8 +5037,8 @@
         </p:nvSpPr>
         <p:spPr>
           <a:xfrm>
-            <a:off x="6629400" y="2756915"/>
-            <a:ext cx="822960" cy="822960"/>
+            <a:off x="6556248" y="2555747"/>
+            <a:ext cx="1188720" cy="1188720"/>
           </a:xfrm>
           <a:prstGeom prst="ellipse">
             <a:avLst/>
@@ -5071,7 +5071,7 @@
           <a:p>
             <a:pPr algn="ctr"/>
             <a:r>
-              <a:rPr sz="1200" b="1" i="0" u="none">
+              <a:rPr sz="1700" b="1" i="0" u="none">
                 <a:solidFill>
                   <a:srgbClr val="262626"/>
                 </a:solidFill>
@@ -5079,21 +5079,72 @@
                 <a:ea typeface="맑은 고딕"/>
                 <a:cs typeface="맑은 고딕"/>
               </a:rPr>
-              <a:t>수개월</a:t>
-            </a:r>
-          </a:p>
-        </p:txBody>
-      </p:sp>
-      <p:sp>
-        <p:nvSpPr>
-          <p:cNvPr id="37" name="Oval 36"/>
+              <a:t>2시간</a:t>
+            </a:r>
+          </a:p>
+          <a:p>
+            <a:pPr algn="ctr"/>
+            <a:r>
+              <a:rPr sz="1700" b="1" i="0" u="none">
+                <a:solidFill>
+                  <a:srgbClr val="262626"/>
+                </a:solidFill>
+                <a:latin typeface="맑은 고딕"/>
+                <a:ea typeface="맑은 고딕"/>
+                <a:cs typeface="맑은 고딕"/>
+              </a:rPr>
+              <a:t>41분</a:t>
+            </a:r>
+          </a:p>
+        </p:txBody>
+      </p:sp>
+      <p:sp>
+        <p:nvSpPr>
+          <p:cNvPr id="37" name="TextBox 36"/>
+          <p:cNvSpPr txBox="1"/>
+          <p:nvPr/>
+        </p:nvSpPr>
+        <p:spPr>
+          <a:xfrm>
+            <a:off x="6537960" y="3790187"/>
+            <a:ext cx="1225296" cy="201168"/>
+          </a:xfrm>
+          <a:prstGeom prst="rect">
+            <a:avLst/>
+          </a:prstGeom>
+          <a:noFill/>
+        </p:spPr>
+        <p:txBody>
+          <a:bodyPr wrap="square" lIns="18288" rIns="18288" tIns="18288" bIns="18288" anchor="ctr">
+            <a:spAutoFit/>
+          </a:bodyPr>
+          <a:lstStyle/>
+          <a:p>
+            <a:pPr algn="ctr"/>
+            <a:r>
+              <a:rPr sz="950" b="0" i="0" u="none">
+                <a:solidFill>
+                  <a:srgbClr val="7F7F7F"/>
+                </a:solidFill>
+                <a:latin typeface="맑은 고딕"/>
+                <a:ea typeface="맑은 고딕"/>
+                <a:cs typeface="맑은 고딕"/>
+              </a:rPr>
+              <a:t>AI 미사용</a:t>
+            </a:r>
+          </a:p>
+        </p:txBody>
+      </p:sp>
+      <p:sp>
+        <p:nvSpPr>
+          <p:cNvPr id="38" name="Oval 37"/>
           <p:cNvSpPr/>
           <p:nvPr/>
         </p:nvSpPr>
         <p:spPr>
           <a:xfrm>
-            <a:off x="7635240" y="2510027"/>
-            <a:ext cx="1316736" cy="1316736"/>
+            <a:off x="7959852" y="2715767"/>
+            <a:ext cx="868680" cy="868680"/>
           </a:xfrm>
           <a:prstGeom prst="ellipse">
             <a:avLst/>
@@ -5126,7 +5177,7 @@
           <a:p>
             <a:pPr algn="ctr"/>
             <a:r>
-              <a:rPr sz="1600" b="1" i="0" u="none">
+              <a:rPr sz="1300" b="1" i="0" u="none">
                 <a:solidFill>
                   <a:srgbClr val="262626"/>
                 </a:solidFill>
@@ -5134,21 +5185,35 @@
                 <a:ea typeface="맑은 고딕"/>
                 <a:cs typeface="맑은 고딕"/>
               </a:rPr>
-              <a:t>수일</a:t>
-            </a:r>
-          </a:p>
-        </p:txBody>
-      </p:sp>
-      <p:sp>
-        <p:nvSpPr>
-          <p:cNvPr id="38" name="TextBox 37"/>
+              <a:t>1시간</a:t>
+            </a:r>
+          </a:p>
+          <a:p>
+            <a:pPr algn="ctr"/>
+            <a:r>
+              <a:rPr sz="1300" b="1" i="0" u="none">
+                <a:solidFill>
+                  <a:srgbClr val="262626"/>
+                </a:solidFill>
+                <a:latin typeface="맑은 고딕"/>
+                <a:ea typeface="맑은 고딕"/>
+                <a:cs typeface="맑은 고딕"/>
+              </a:rPr>
+              <a:t>11분</a:t>
+            </a:r>
+          </a:p>
+        </p:txBody>
+      </p:sp>
+      <p:sp>
+        <p:nvSpPr>
+          <p:cNvPr id="39" name="TextBox 38"/>
           <p:cNvSpPr txBox="1"/>
           <p:nvPr/>
         </p:nvSpPr>
         <p:spPr>
           <a:xfrm>
-            <a:off x="6629400" y="3854196"/>
-            <a:ext cx="822960" cy="201168"/>
+            <a:off x="7781544" y="3790187"/>
+            <a:ext cx="1225296" cy="201168"/>
           </a:xfrm>
           <a:prstGeom prst="rect">
             <a:avLst/>
@@ -5163,43 +5228,6 @@
           <a:p>
             <a:pPr algn="ctr"/>
             <a:r>
-              <a:rPr sz="950" b="0" i="0" u="none">
-                <a:solidFill>
-                  <a:srgbClr val="7F7F7F"/>
-                </a:solidFill>
-                <a:latin typeface="맑은 고딕"/>
-                <a:ea typeface="맑은 고딕"/>
-                <a:cs typeface="맑은 고딕"/>
-              </a:rPr>
-              <a:t>As-Is</a:t>
-            </a:r>
-          </a:p>
-        </p:txBody>
-      </p:sp>
-      <p:sp>
-        <p:nvSpPr>
-          <p:cNvPr id="39" name="TextBox 38"/>
-          <p:cNvSpPr txBox="1"/>
-          <p:nvPr/>
-        </p:nvSpPr>
-        <p:spPr>
-          <a:xfrm>
-            <a:off x="7635240" y="3854196"/>
-            <a:ext cx="1316736" cy="201168"/>
-          </a:xfrm>
-          <a:prstGeom prst="rect">
-            <a:avLst/>
-          </a:prstGeom>
-          <a:noFill/>
-        </p:spPr>
-        <p:txBody>
-          <a:bodyPr wrap="square" lIns="18288" rIns="18288" tIns="18288" bIns="18288" anchor="ctr">
-            <a:spAutoFit/>
-          </a:bodyPr>
-          <a:lstStyle/>
-          <a:p>
-            <a:pPr algn="ctr"/>
-            <a:r>
               <a:rPr sz="950" b="1" i="0" u="none">
                 <a:solidFill>
                   <a:srgbClr val="262626"/>
@@ -5208,7 +5236,7 @@
                 <a:ea typeface="맑은 고딕"/>
                 <a:cs typeface="맑은 고딕"/>
               </a:rPr>
-              <a:t>To-Be</a:t>
+              <a:t>AI 사용 (-55%)</a:t>
             </a:r>
           </a:p>
         </p:txBody>
@@ -5255,7 +5283,7 @@
           <a:p>
             <a:pPr algn="ctr"/>
             <a:r>
-              <a:rPr sz="1300" b="1" i="0" u="none">
+              <a:rPr sz="1200" b="1" i="0" u="none">
                 <a:solidFill>
                   <a:srgbClr val="FFFFFF"/>
                 </a:solidFill>
@@ -5263,7 +5291,7 @@
                 <a:ea typeface="맑은 고딕"/>
                 <a:cs typeface="맑은 고딕"/>
               </a:rPr>
-              <a:t>의사결정 근거</a:t>
+              <a:t>코딩 작업 속도 ②</a:t>
             </a:r>
           </a:p>
         </p:txBody>
@@ -5276,8 +5304,8 @@
         </p:nvSpPr>
         <p:spPr>
           <a:xfrm>
-            <a:off x="9281160" y="2756915"/>
-            <a:ext cx="822960" cy="822960"/>
+            <a:off x="9413748" y="2761487"/>
+            <a:ext cx="777240" cy="777240"/>
           </a:xfrm>
           <a:prstGeom prst="ellipse">
             <a:avLst/>
@@ -5310,7 +5338,7 @@
           <a:p>
             <a:pPr algn="ctr"/>
             <a:r>
-              <a:rPr sz="1200" b="1" i="0" u="none">
+              <a:rPr sz="1300" b="1" i="0" u="none">
                 <a:solidFill>
                   <a:srgbClr val="262626"/>
                 </a:solidFill>
@@ -5318,35 +5346,58 @@
                 <a:ea typeface="맑은 고딕"/>
                 <a:cs typeface="맑은 고딕"/>
               </a:rPr>
-              <a:t>기획</a:t>
-            </a:r>
-          </a:p>
-          <a:p>
-            <a:pPr algn="ctr"/>
-            <a:r>
-              <a:rPr sz="1200" b="1" i="0" u="none">
-                <a:solidFill>
-                  <a:srgbClr val="262626"/>
-                </a:solidFill>
-                <a:latin typeface="맑은 고딕"/>
-                <a:ea typeface="맑은 고딕"/>
-                <a:cs typeface="맑은 고딕"/>
-              </a:rPr>
-              <a:t>문서</a:t>
-            </a:r>
-          </a:p>
-        </p:txBody>
-      </p:sp>
-      <p:sp>
-        <p:nvSpPr>
-          <p:cNvPr id="42" name="Oval 41"/>
+              <a:t>1배</a:t>
+            </a:r>
+          </a:p>
+        </p:txBody>
+      </p:sp>
+      <p:sp>
+        <p:nvSpPr>
+          <p:cNvPr id="42" name="TextBox 41"/>
+          <p:cNvSpPr txBox="1"/>
+          <p:nvPr/>
+        </p:nvSpPr>
+        <p:spPr>
+          <a:xfrm>
+            <a:off x="9189720" y="3790187"/>
+            <a:ext cx="1225296" cy="201168"/>
+          </a:xfrm>
+          <a:prstGeom prst="rect">
+            <a:avLst/>
+          </a:prstGeom>
+          <a:noFill/>
+        </p:spPr>
+        <p:txBody>
+          <a:bodyPr wrap="square" lIns="18288" rIns="18288" tIns="18288" bIns="18288" anchor="ctr">
+            <a:spAutoFit/>
+          </a:bodyPr>
+          <a:lstStyle/>
+          <a:p>
+            <a:pPr algn="ctr"/>
+            <a:r>
+              <a:rPr sz="950" b="0" i="0" u="none">
+                <a:solidFill>
+                  <a:srgbClr val="7F7F7F"/>
+                </a:solidFill>
+                <a:latin typeface="맑은 고딕"/>
+                <a:ea typeface="맑은 고딕"/>
+                <a:cs typeface="맑은 고딕"/>
+              </a:rPr>
+              <a:t>기존 방식</a:t>
+            </a:r>
+          </a:p>
+        </p:txBody>
+      </p:sp>
+      <p:sp>
+        <p:nvSpPr>
+          <p:cNvPr id="43" name="Oval 42"/>
           <p:cNvSpPr/>
           <p:nvPr/>
         </p:nvSpPr>
         <p:spPr>
           <a:xfrm>
-            <a:off x="10287000" y="2510027"/>
-            <a:ext cx="1316736" cy="1316736"/>
+            <a:off x="10451592" y="2555747"/>
+            <a:ext cx="1188720" cy="1188720"/>
           </a:xfrm>
           <a:prstGeom prst="ellipse">
             <a:avLst/>
@@ -5379,7 +5430,7 @@
           <a:p>
             <a:pPr algn="ctr"/>
             <a:r>
-              <a:rPr sz="1600" b="1" i="0" u="none">
+              <a:rPr sz="1700" b="1" i="0" u="none">
                 <a:solidFill>
                   <a:srgbClr val="262626"/>
                 </a:solidFill>
@@ -5387,13 +5438,13 @@
                 <a:ea typeface="맑은 고딕"/>
                 <a:cs typeface="맑은 고딕"/>
               </a:rPr>
-              <a:t>작동</a:t>
-            </a:r>
-          </a:p>
-          <a:p>
-            <a:pPr algn="ctr"/>
-            <a:r>
-              <a:rPr sz="1600" b="1" i="0" u="none">
+              <a:t>최대</a:t>
+            </a:r>
+          </a:p>
+          <a:p>
+            <a:pPr algn="ctr"/>
+            <a:r>
+              <a:rPr sz="1700" b="1" i="0" u="none">
                 <a:solidFill>
                   <a:srgbClr val="262626"/>
                 </a:solidFill>
@@ -5401,21 +5452,21 @@
                 <a:ea typeface="맑은 고딕"/>
                 <a:cs typeface="맑은 고딕"/>
               </a:rPr>
-              <a:t>화면</a:t>
-            </a:r>
-          </a:p>
-        </p:txBody>
-      </p:sp>
-      <p:sp>
-        <p:nvSpPr>
-          <p:cNvPr id="43" name="TextBox 42"/>
+              <a:t>2배</a:t>
+            </a:r>
+          </a:p>
+        </p:txBody>
+      </p:sp>
+      <p:sp>
+        <p:nvSpPr>
+          <p:cNvPr id="44" name="TextBox 43"/>
           <p:cNvSpPr txBox="1"/>
           <p:nvPr/>
         </p:nvSpPr>
         <p:spPr>
           <a:xfrm>
-            <a:off x="9281160" y="3854196"/>
-            <a:ext cx="822960" cy="201168"/>
+            <a:off x="10433304" y="3790187"/>
+            <a:ext cx="1225296" cy="201168"/>
           </a:xfrm>
           <a:prstGeom prst="rect">
             <a:avLst/>
@@ -5430,43 +5481,6 @@
           <a:p>
             <a:pPr algn="ctr"/>
             <a:r>
-              <a:rPr sz="950" b="0" i="0" u="none">
-                <a:solidFill>
-                  <a:srgbClr val="7F7F7F"/>
-                </a:solidFill>
-                <a:latin typeface="맑은 고딕"/>
-                <a:ea typeface="맑은 고딕"/>
-                <a:cs typeface="맑은 고딕"/>
-              </a:rPr>
-              <a:t>As-Is</a:t>
-            </a:r>
-          </a:p>
-        </p:txBody>
-      </p:sp>
-      <p:sp>
-        <p:nvSpPr>
-          <p:cNvPr id="44" name="TextBox 43"/>
-          <p:cNvSpPr txBox="1"/>
-          <p:nvPr/>
-        </p:nvSpPr>
-        <p:spPr>
-          <a:xfrm>
-            <a:off x="10287000" y="3854196"/>
-            <a:ext cx="1316736" cy="201168"/>
-          </a:xfrm>
-          <a:prstGeom prst="rect">
-            <a:avLst/>
-          </a:prstGeom>
-          <a:noFill/>
-        </p:spPr>
-        <p:txBody>
-          <a:bodyPr wrap="square" lIns="18288" rIns="18288" tIns="18288" bIns="18288" anchor="ctr">
-            <a:spAutoFit/>
-          </a:bodyPr>
-          <a:lstStyle/>
-          <a:p>
-            <a:pPr algn="ctr"/>
-            <a:r>
               <a:rPr sz="950" b="1" i="0" u="none">
                 <a:solidFill>
                   <a:srgbClr val="262626"/>
@@ -5475,7 +5489,7 @@
                 <a:ea typeface="맑은 고딕"/>
                 <a:cs typeface="맑은 고딕"/>
               </a:rPr>
-              <a:t>To-Be</a:t>
+              <a:t>생성형 AI 활용</a:t>
             </a:r>
           </a:p>
         </p:txBody>
@@ -5522,7 +5536,7 @@
           <a:p>
             <a:pPr algn="ctr"/>
             <a:r>
-              <a:rPr sz="1300" b="1" i="0" u="none">
+              <a:rPr sz="1200" b="1" i="0" u="none">
                 <a:solidFill>
                   <a:srgbClr val="FFFFFF"/>
                 </a:solidFill>
@@ -5530,7 +5544,7 @@
                 <a:ea typeface="맑은 고딕"/>
                 <a:cs typeface="맑은 고딕"/>
               </a:rPr>
-              <a:t>구현 참여 주체</a:t>
+              <a:t>바이브 코딩 사용자 구성 ③</a:t>
             </a:r>
           </a:p>
         </p:txBody>
@@ -5543,8 +5557,8 @@
         </p:nvSpPr>
         <p:spPr>
           <a:xfrm>
-            <a:off x="6629400" y="4832604"/>
-            <a:ext cx="822960" cy="822960"/>
+            <a:off x="6716268" y="4791456"/>
+            <a:ext cx="868680" cy="868680"/>
           </a:xfrm>
           <a:prstGeom prst="ellipse">
             <a:avLst/>
@@ -5577,7 +5591,7 @@
           <a:p>
             <a:pPr algn="ctr"/>
             <a:r>
-              <a:rPr sz="1200" b="1" i="0" u="none">
+              <a:rPr sz="1300" b="1" i="0" u="none">
                 <a:solidFill>
                   <a:srgbClr val="262626"/>
                 </a:solidFill>
@@ -5585,35 +5599,58 @@
                 <a:ea typeface="맑은 고딕"/>
                 <a:cs typeface="맑은 고딕"/>
               </a:rPr>
-              <a:t>IT</a:t>
-            </a:r>
-          </a:p>
-          <a:p>
-            <a:pPr algn="ctr"/>
-            <a:r>
-              <a:rPr sz="1200" b="1" i="0" u="none">
-                <a:solidFill>
-                  <a:srgbClr val="262626"/>
-                </a:solidFill>
-                <a:latin typeface="맑은 고딕"/>
-                <a:ea typeface="맑은 고딕"/>
-                <a:cs typeface="맑은 고딕"/>
-              </a:rPr>
-              <a:t>개발팀</a:t>
-            </a:r>
-          </a:p>
-        </p:txBody>
-      </p:sp>
-      <p:sp>
-        <p:nvSpPr>
-          <p:cNvPr id="47" name="Oval 46"/>
+              <a:t>37%</a:t>
+            </a:r>
+          </a:p>
+        </p:txBody>
+      </p:sp>
+      <p:sp>
+        <p:nvSpPr>
+          <p:cNvPr id="47" name="TextBox 46"/>
+          <p:cNvSpPr txBox="1"/>
+          <p:nvPr/>
+        </p:nvSpPr>
+        <p:spPr>
+          <a:xfrm>
+            <a:off x="6537960" y="5865876"/>
+            <a:ext cx="1225296" cy="201168"/>
+          </a:xfrm>
+          <a:prstGeom prst="rect">
+            <a:avLst/>
+          </a:prstGeom>
+          <a:noFill/>
+        </p:spPr>
+        <p:txBody>
+          <a:bodyPr wrap="square" lIns="18288" rIns="18288" tIns="18288" bIns="18288" anchor="ctr">
+            <a:spAutoFit/>
+          </a:bodyPr>
+          <a:lstStyle/>
+          <a:p>
+            <a:pPr algn="ctr"/>
+            <a:r>
+              <a:rPr sz="950" b="0" i="0" u="none">
+                <a:solidFill>
+                  <a:srgbClr val="7F7F7F"/>
+                </a:solidFill>
+                <a:latin typeface="맑은 고딕"/>
+                <a:ea typeface="맑은 고딕"/>
+                <a:cs typeface="맑은 고딕"/>
+              </a:rPr>
+              <a:t>개발자</a:t>
+            </a:r>
+          </a:p>
+        </p:txBody>
+      </p:sp>
+      <p:sp>
+        <p:nvSpPr>
+          <p:cNvPr id="48" name="Oval 47"/>
           <p:cNvSpPr/>
           <p:nvPr/>
         </p:nvSpPr>
         <p:spPr>
           <a:xfrm>
-            <a:off x="7635240" y="4585716"/>
-            <a:ext cx="1316736" cy="1316736"/>
+            <a:off x="7799831" y="4631436"/>
+            <a:ext cx="1188720" cy="1188720"/>
           </a:xfrm>
           <a:prstGeom prst="ellipse">
             <a:avLst/>
@@ -5646,7 +5683,7 @@
           <a:p>
             <a:pPr algn="ctr"/>
             <a:r>
-              <a:rPr sz="1600" b="1" i="0" u="none">
+              <a:rPr sz="1700" b="1" i="0" u="none">
                 <a:solidFill>
                   <a:srgbClr val="262626"/>
                 </a:solidFill>
@@ -5654,35 +5691,21 @@
                 <a:ea typeface="맑은 고딕"/>
                 <a:cs typeface="맑은 고딕"/>
               </a:rPr>
-              <a:t>현업 +</a:t>
-            </a:r>
-          </a:p>
-          <a:p>
-            <a:pPr algn="ctr"/>
-            <a:r>
-              <a:rPr sz="1600" b="1" i="0" u="none">
-                <a:solidFill>
-                  <a:srgbClr val="262626"/>
-                </a:solidFill>
-                <a:latin typeface="맑은 고딕"/>
-                <a:ea typeface="맑은 고딕"/>
-                <a:cs typeface="맑은 고딕"/>
-              </a:rPr>
-              <a:t>컨설턴트</a:t>
-            </a:r>
-          </a:p>
-        </p:txBody>
-      </p:sp>
-      <p:sp>
-        <p:nvSpPr>
-          <p:cNvPr id="48" name="TextBox 47"/>
+              <a:t>63%</a:t>
+            </a:r>
+          </a:p>
+        </p:txBody>
+      </p:sp>
+      <p:sp>
+        <p:nvSpPr>
+          <p:cNvPr id="49" name="TextBox 48"/>
           <p:cNvSpPr txBox="1"/>
           <p:nvPr/>
         </p:nvSpPr>
         <p:spPr>
           <a:xfrm>
-            <a:off x="6629400" y="5929884"/>
-            <a:ext cx="822960" cy="201168"/>
+            <a:off x="7781544" y="5865876"/>
+            <a:ext cx="1225296" cy="201168"/>
           </a:xfrm>
           <a:prstGeom prst="rect">
             <a:avLst/>
@@ -5697,43 +5720,6 @@
           <a:p>
             <a:pPr algn="ctr"/>
             <a:r>
-              <a:rPr sz="950" b="0" i="0" u="none">
-                <a:solidFill>
-                  <a:srgbClr val="7F7F7F"/>
-                </a:solidFill>
-                <a:latin typeface="맑은 고딕"/>
-                <a:ea typeface="맑은 고딕"/>
-                <a:cs typeface="맑은 고딕"/>
-              </a:rPr>
-              <a:t>As-Is</a:t>
-            </a:r>
-          </a:p>
-        </p:txBody>
-      </p:sp>
-      <p:sp>
-        <p:nvSpPr>
-          <p:cNvPr id="49" name="TextBox 48"/>
-          <p:cNvSpPr txBox="1"/>
-          <p:nvPr/>
-        </p:nvSpPr>
-        <p:spPr>
-          <a:xfrm>
-            <a:off x="7635240" y="5929884"/>
-            <a:ext cx="1316736" cy="201168"/>
-          </a:xfrm>
-          <a:prstGeom prst="rect">
-            <a:avLst/>
-          </a:prstGeom>
-          <a:noFill/>
-        </p:spPr>
-        <p:txBody>
-          <a:bodyPr wrap="square" lIns="18288" rIns="18288" tIns="18288" bIns="18288" anchor="ctr">
-            <a:spAutoFit/>
-          </a:bodyPr>
-          <a:lstStyle/>
-          <a:p>
-            <a:pPr algn="ctr"/>
-            <a:r>
               <a:rPr sz="950" b="1" i="0" u="none">
                 <a:solidFill>
                   <a:srgbClr val="262626"/>
@@ -5742,7 +5728,7 @@
                 <a:ea typeface="맑은 고딕"/>
                 <a:cs typeface="맑은 고딕"/>
               </a:rPr>
-              <a:t>To-Be</a:t>
+              <a:t>비개발자</a:t>
             </a:r>
           </a:p>
         </p:txBody>
@@ -5789,7 +5775,7 @@
           <a:p>
             <a:pPr algn="ctr"/>
             <a:r>
-              <a:rPr sz="1300" b="1" i="0" u="none">
+              <a:rPr sz="1200" b="1" i="0" u="none">
                 <a:solidFill>
                   <a:srgbClr val="FFFFFF"/>
                 </a:solidFill>
@@ -5797,7 +5783,7 @@
                 <a:ea typeface="맑은 고딕"/>
                 <a:cs typeface="맑은 고딕"/>
               </a:rPr>
-              <a:t>피드백 반복</a:t>
+              <a:t>Google 신규 코드 중 AI 비중 ④</a:t>
             </a:r>
           </a:p>
         </p:txBody>
@@ -5810,8 +5796,8 @@
         </p:nvSpPr>
         <p:spPr>
           <a:xfrm>
-            <a:off x="9281160" y="4832604"/>
-            <a:ext cx="822960" cy="822960"/>
+            <a:off x="9436608" y="4860036"/>
+            <a:ext cx="731520" cy="731520"/>
           </a:xfrm>
           <a:prstGeom prst="ellipse">
             <a:avLst/>
@@ -5844,7 +5830,7 @@
           <a:p>
             <a:pPr algn="ctr"/>
             <a:r>
-              <a:rPr sz="1200" b="1" i="0" u="none">
+              <a:rPr sz="1300" b="1" i="0" u="none">
                 <a:solidFill>
                   <a:srgbClr val="262626"/>
                 </a:solidFill>
@@ -5852,21 +5838,58 @@
                 <a:ea typeface="맑은 고딕"/>
                 <a:cs typeface="맑은 고딕"/>
               </a:rPr>
-              <a:t>1~2회</a:t>
-            </a:r>
-          </a:p>
-        </p:txBody>
-      </p:sp>
-      <p:sp>
-        <p:nvSpPr>
-          <p:cNvPr id="52" name="Oval 51"/>
+              <a:t>25%</a:t>
+            </a:r>
+          </a:p>
+        </p:txBody>
+      </p:sp>
+      <p:sp>
+        <p:nvSpPr>
+          <p:cNvPr id="52" name="TextBox 51"/>
+          <p:cNvSpPr txBox="1"/>
+          <p:nvPr/>
+        </p:nvSpPr>
+        <p:spPr>
+          <a:xfrm>
+            <a:off x="9189720" y="5865876"/>
+            <a:ext cx="1225296" cy="201168"/>
+          </a:xfrm>
+          <a:prstGeom prst="rect">
+            <a:avLst/>
+          </a:prstGeom>
+          <a:noFill/>
+        </p:spPr>
+        <p:txBody>
+          <a:bodyPr wrap="square" lIns="18288" rIns="18288" tIns="18288" bIns="18288" anchor="ctr">
+            <a:spAutoFit/>
+          </a:bodyPr>
+          <a:lstStyle/>
+          <a:p>
+            <a:pPr algn="ctr"/>
+            <a:r>
+              <a:rPr sz="950" b="0" i="0" u="none">
+                <a:solidFill>
+                  <a:srgbClr val="7F7F7F"/>
+                </a:solidFill>
+                <a:latin typeface="맑은 고딕"/>
+                <a:ea typeface="맑은 고딕"/>
+                <a:cs typeface="맑은 고딕"/>
+              </a:rPr>
+              <a:t>'24.10</a:t>
+            </a:r>
+          </a:p>
+        </p:txBody>
+      </p:sp>
+      <p:sp>
+        <p:nvSpPr>
+          <p:cNvPr id="53" name="Oval 52"/>
           <p:cNvSpPr/>
           <p:nvPr/>
         </p:nvSpPr>
         <p:spPr>
           <a:xfrm>
-            <a:off x="10287000" y="4585716"/>
-            <a:ext cx="1316736" cy="1316736"/>
+            <a:off x="10451592" y="4631436"/>
+            <a:ext cx="1188720" cy="1188720"/>
           </a:xfrm>
           <a:prstGeom prst="ellipse">
             <a:avLst/>
@@ -5899,7 +5922,7 @@
           <a:p>
             <a:pPr algn="ctr"/>
             <a:r>
-              <a:rPr sz="1600" b="1" i="0" u="none">
+              <a:rPr sz="1700" b="1" i="0" u="none">
                 <a:solidFill>
                   <a:srgbClr val="262626"/>
                 </a:solidFill>
@@ -5907,35 +5930,21 @@
                 <a:ea typeface="맑은 고딕"/>
                 <a:cs typeface="맑은 고딕"/>
               </a:rPr>
-              <a:t>상시</a:t>
-            </a:r>
-          </a:p>
-          <a:p>
-            <a:pPr algn="ctr"/>
-            <a:r>
-              <a:rPr sz="1600" b="1" i="0" u="none">
-                <a:solidFill>
-                  <a:srgbClr val="262626"/>
-                </a:solidFill>
-                <a:latin typeface="맑은 고딕"/>
-                <a:ea typeface="맑은 고딕"/>
-                <a:cs typeface="맑은 고딕"/>
-              </a:rPr>
-              <a:t>반복</a:t>
-            </a:r>
-          </a:p>
-        </p:txBody>
-      </p:sp>
-      <p:sp>
-        <p:nvSpPr>
-          <p:cNvPr id="53" name="TextBox 52"/>
+              <a:t>75%</a:t>
+            </a:r>
+          </a:p>
+        </p:txBody>
+      </p:sp>
+      <p:sp>
+        <p:nvSpPr>
+          <p:cNvPr id="54" name="TextBox 53"/>
           <p:cNvSpPr txBox="1"/>
           <p:nvPr/>
         </p:nvSpPr>
         <p:spPr>
           <a:xfrm>
-            <a:off x="9281160" y="5929884"/>
-            <a:ext cx="822960" cy="201168"/>
+            <a:off x="10433304" y="5865876"/>
+            <a:ext cx="1225296" cy="201168"/>
           </a:xfrm>
           <a:prstGeom prst="rect">
             <a:avLst/>
@@ -5950,43 +5959,6 @@
           <a:p>
             <a:pPr algn="ctr"/>
             <a:r>
-              <a:rPr sz="950" b="0" i="0" u="none">
-                <a:solidFill>
-                  <a:srgbClr val="7F7F7F"/>
-                </a:solidFill>
-                <a:latin typeface="맑은 고딕"/>
-                <a:ea typeface="맑은 고딕"/>
-                <a:cs typeface="맑은 고딕"/>
-              </a:rPr>
-              <a:t>As-Is</a:t>
-            </a:r>
-          </a:p>
-        </p:txBody>
-      </p:sp>
-      <p:sp>
-        <p:nvSpPr>
-          <p:cNvPr id="54" name="TextBox 53"/>
-          <p:cNvSpPr txBox="1"/>
-          <p:nvPr/>
-        </p:nvSpPr>
-        <p:spPr>
-          <a:xfrm>
-            <a:off x="10287000" y="5929884"/>
-            <a:ext cx="1316736" cy="201168"/>
-          </a:xfrm>
-          <a:prstGeom prst="rect">
-            <a:avLst/>
-          </a:prstGeom>
-          <a:noFill/>
-        </p:spPr>
-        <p:txBody>
-          <a:bodyPr wrap="square" lIns="18288" rIns="18288" tIns="18288" bIns="18288" anchor="ctr">
-            <a:spAutoFit/>
-          </a:bodyPr>
-          <a:lstStyle/>
-          <a:p>
-            <a:pPr algn="ctr"/>
-            <a:r>
               <a:rPr sz="950" b="1" i="0" u="none">
                 <a:solidFill>
                   <a:srgbClr val="262626"/>
@@ -5995,7 +5967,7 @@
                 <a:ea typeface="맑은 고딕"/>
                 <a:cs typeface="맑은 고딕"/>
               </a:rPr>
-              <a:t>To-Be</a:t>
+              <a:t>'26</a:t>
             </a:r>
           </a:p>
         </p:txBody>
@@ -6063,8 +6035,8 @@
         </p:nvSpPr>
         <p:spPr>
           <a:xfrm>
-            <a:off x="365760" y="6400800"/>
-            <a:ext cx="11430000" cy="274320"/>
+            <a:off x="365760" y="6336792"/>
+            <a:ext cx="11521440" cy="457200"/>
           </a:xfrm>
           <a:prstGeom prst="rect">
             <a:avLst/>
@@ -6072,14 +6044,14 @@
           <a:noFill/>
         </p:spPr>
         <p:txBody>
-          <a:bodyPr wrap="square" lIns="18288" rIns="18288" tIns="18288" bIns="18288" anchor="ctr">
+          <a:bodyPr wrap="square" lIns="18288" rIns="18288" tIns="18288" bIns="18288" anchor="t">
             <a:spAutoFit/>
           </a:bodyPr>
           <a:lstStyle/>
           <a:p>
             <a:pPr algn="l"/>
             <a:r>
-              <a:rPr sz="950" b="0" i="0" u="none">
+              <a:rPr sz="850" b="0" i="0" u="none">
                 <a:solidFill>
                   <a:srgbClr val="7F7F7F"/>
                 </a:solidFill>
@@ -6087,7 +6059,21 @@
                 <a:ea typeface="맑은 고딕"/>
                 <a:cs typeface="맑은 고딕"/>
               </a:rPr>
-              <a:t>※ 바이브 코딩: 자연어 지시만으로 AI가 코드를 생성해 빠르게 화면을 구현하는 방식  /  우측 비교는 일반적인 경향을 나타낸 예시임</a:t>
+              <a:t>※ 바이브 코딩: 자연어 지시만으로 AI가 코드를 생성해 빠르게 화면을 구현하는 방식</a:t>
+            </a:r>
+          </a:p>
+          <a:p>
+            <a:pPr algn="l"/>
+            <a:r>
+              <a:rPr sz="850" b="0" i="0" u="none">
+                <a:solidFill>
+                  <a:srgbClr val="7F7F7F"/>
+                </a:solidFill>
+                <a:latin typeface="맑은 고딕"/>
+                <a:ea typeface="맑은 고딕"/>
+                <a:cs typeface="맑은 고딕"/>
+              </a:rPr>
+              <a:t>출처: ① GitHub, Copilot 대조 실험 (2022, 개발자 95명)  ② McKinsey, Unleashing developer productivity with generative AI (2023)  ③ Vercel v0, State of Vibe Coding (2025)  ④ Alphabet CEO 발언 (실적발표 '24.10, Google Cloud Next '26)</a:t>
             </a:r>
           </a:p>
         </p:txBody>

</xml_diff>